<commit_message>
docs(presentation): add 5-min hackathon pitch script, QnA defense guide, and updated master pptx
</commit_message>
<xml_diff>
--- a/presentation/Bside_Presentation_Master.pptx
+++ b/presentation/Bside_Presentation_Master.pptx
@@ -355,18 +355,21 @@
             <a:pPr/>
             <a:r>
               <a:rPr lang="ko-KR" dirty="0"/>
-              <a:t>안녕하십니까, 행사장에서 닿을 수 있는 거리에 있는 사람과 이어지는 상보성 AI 네트워킹 서비스, Bside 발표를 맡은 [이름]입니다.</a:t>
+              <a:t>[00:00 ~ 00:30] Slide 01: 표지 — Hook &amp; Vision</a:t>
             </a:r>
-          </a:p>
-          <a:p>
-            <a:pPr/>
-            <a:endParaRPr lang="ko-KR" dirty="0"/>
           </a:p>
           <a:p>
             <a:pPr/>
             <a:r>
               <a:rPr lang="ko-KR" dirty="0"/>
-              <a:t>저희는 오늘 코쓱톤의 주제인 "교류"에 대해 가장 본질적인 질문을 던지고자 합니다.</a:t>
+              <a:t>"여러분, 오늘 해커톤 현장에 도착하셨을 때 어떠셨나요? 로비에 100명이 넘는 사람이 모여 있지만, 막상 먼저 다가가 말을 건네기는 정말 어렵지 않으셨습니까?</a:t>
+            </a:r>
+          </a:p>
+          <a:p>
+            <a:pPr/>
+            <a:r>
+              <a:rPr lang="ko-KR" dirty="0"/>
+              <a:t>안녕하십니까, 행사장에서 닿을 수 있는 거리에 있는 사람과 이어지는 상보성 AI 네트워킹, Bside 팀입니다."</a:t>
             </a:r>
           </a:p>
         </p:txBody>
@@ -426,36 +429,21 @@
             <a:pPr/>
             <a:r>
               <a:rPr lang="ko-KR" dirty="0"/>
-              <a:t>온라인에는 상태 메시지가 있었지만, 현실에는 없었습니다.</a:t>
+              <a:t>[05:00 ~ 05:20] Slide 10: 결론 및 비전 — Closing &amp; Call to Action</a:t>
             </a:r>
           </a:p>
           <a:p>
             <a:pPr/>
             <a:r>
               <a:rPr lang="ko-KR" dirty="0"/>
-              <a:t>Bside는 닿을 수 있는 거리에 있는 두 사람의 결핍과 경험을 AI로 이어냅니다.</a:t>
+              <a:t>"'사람과 사람 사이, 가장 어려운 첫 마디를 기술로 건넵니다.'</a:t>
             </a:r>
-          </a:p>
-          <a:p>
-            <a:pPr/>
-            <a:endParaRPr lang="ko-KR" dirty="0"/>
           </a:p>
           <a:p>
             <a:pPr/>
             <a:r>
               <a:rPr lang="ko-KR" dirty="0"/>
-              <a:t>채팅은 만나기 위한 도구일 뿐이며, 우리의 진짜 결과물은 현실에서의 만남입니다.</a:t>
-            </a:r>
-          </a:p>
-          <a:p>
-            <a:pPr/>
-            <a:endParaRPr lang="ko-KR" dirty="0"/>
-          </a:p>
-          <a:p>
-            <a:pPr/>
-            <a:r>
-              <a:rPr lang="ko-KR" dirty="0"/>
-              <a:t>Connect with who is beside you — Bside였습니다. 경청해 주셔서 감사합니다!</a:t>
+              <a:t>행사장에서 내 바로 곁에 있는 가장 필요한 사람을 찾아주는 플랫폼, Bside였습니다. 지금 화면의 QR 코드로 직접 체험해 보실 수 있습니다. 경청해 주셔서 감사합니다. 질의응답 받겠습니다!"</a:t>
             </a:r>
           </a:p>
         </p:txBody>
@@ -515,29 +503,21 @@
             <a:pPr/>
             <a:r>
               <a:rPr lang="ko-KR" dirty="0"/>
-              <a:t>여러분, 컨퍼런스나 해커톤에 혼자 갔을 때, 네트워킹 시간에 음료 테이블 옆에 어색하게 서서 스마트폰만 들여다본 적 있으십니까?</a:t>
+              <a:t>[00:30 ~ 01:15] Slide 02: 문제 정의 — The Dilemma</a:t>
             </a:r>
-          </a:p>
-          <a:p>
-            <a:pPr/>
-            <a:endParaRPr lang="ko-KR" dirty="0"/>
           </a:p>
           <a:p>
             <a:pPr/>
             <a:r>
               <a:rPr lang="ko-KR" dirty="0"/>
-              <a:t>말을 걸 용기가 없어서가 아닙니다. 상대방이 누구인지, 그리고 내가 왜 저 사람에게 말을 걸어야 하는지 그 "근거"를 모르기 때문입니다.</a:t>
+              <a:t>"네트워킹 시간 30분이 주어지면, 대부분 이미 아는 사람들끼리 모이거나 어색함을 피하려 스마트폰만 보게 됩니다. 참가자 90%가 느끼는 이 장벽은 용기가 없어서가 아니라 '누구에게, 왜 말을 걸어야 하는지' 그 구체적인 근거를 모르기 때문입니다.</a:t>
             </a:r>
-          </a:p>
-          <a:p>
-            <a:pPr/>
-            <a:endParaRPr lang="ko-KR" dirty="0"/>
           </a:p>
           <a:p>
             <a:pPr/>
             <a:r>
               <a:rPr lang="ko-KR" dirty="0"/>
-              <a:t>글로벌 이벤트 조사에 따르면 주최자의 단 15%만이 자사 네트워킹이 효과적이었다고 답했습니다. 기존 전용 네트워킹 앱들은 무거운 다운로드와 긴 프로필 작성 때문에 채택률이 50%도 안 됩니다. 돈을 들여 앱을 깔게 해도 절반 이상이 안 쓴다는 것이 오프라인 네트워킹의 가장 큰 문제입니다.</a:t>
+              <a:t>기존 네트워킹 앱들은 왜 실패했을까요? 주최자의 단 15%만이 효과적이라 답했습니다. 현장에서 수십 MB 앱을 깔고 20개 넘는 프로필을 적어야 하는 극심한 진입 장벽 때문에 앱 설치율은 58%에 불과했습니다. 아무리 비싼 솔루션을 써도, 현장의 절반 이상은 입조차 떼지 못하고 있습니다."</a:t>
             </a:r>
           </a:p>
         </p:txBody>
@@ -597,39 +577,42 @@
             <a:pPr/>
             <a:r>
               <a:rPr lang="ko-KR" dirty="0"/>
-              <a:t>온라인에는 슬랙이나 디스코드처럼 상태 메시지가 있는데, 왜 우리가 서 있는 이 현실 공간에는 없을까요? Bside는 현실에 상태 인터페이스를 부여합니다.</a:t>
-            </a:r>
-          </a:p>
-          <a:p>
-            <a:pPr/>
-            <a:endParaRPr lang="ko-KR" dirty="0"/>
-          </a:p>
-          <a:p>
-            <a:pPr/>
-            <a:r>
-              <a:rPr lang="ko-KR" dirty="0"/>
-              <a:t>첫째, QR로 3초 입장입니다. 앱 설치 없이 현장 QR을 찍으면 브라우저에서 3초 만에 바로 열립니다.</a:t>
+              <a:t>[01:15 ~ 01:55] Slide 03: 솔루션 — Frictionless 4-Steps</a:t>
             </a:r>
           </a:p>
           <a:p>
             <a:pPr/>
             <a:r>
               <a:rPr lang="ko-KR" dirty="0"/>
-              <a:t>둘째, 30초 한 줄 상태 등록입니다. 닉네임과 내 고민 한 줄을 올려야 46명의 방이 열리는 "올려야 열린다"는 참여 규칙을 적용했습니다.</a:t>
+              <a:t>"Bside는 네트워킹의 모든 마찰을 기술로 완전히 제거했습니다.</a:t>
             </a:r>
           </a:p>
           <a:p>
             <a:pPr/>
             <a:r>
               <a:rPr lang="ko-KR" dirty="0"/>
-              <a:t>셋째, AI 상보성 매칭입니다. 겹치는 단어가 0개라도 결핍과 경험이 맞물리는 사람을 AI가 찾아냅니다.</a:t>
+              <a:t>첫째, 앱 다운로드가 전혀 없습니다. 테이블의 QR을 비추면 3초 만에 모바일 웹으로 즉시 입장합니다.</a:t>
             </a:r>
           </a:p>
           <a:p>
             <a:pPr/>
             <a:r>
               <a:rPr lang="ko-KR" dirty="0"/>
-              <a:t>넷째, BLE 직접 연결을 통해 "창가 쪽 손 들게요" 세 마디 후 폰을 넣고 현실에서 만납니다.</a:t>
+              <a:t>둘째, 30초 한 줄 프로필입니다. 복잡한 이력서 대신 '지금 고민 1줄'과 '나눠줄 역량 1줄'만 적습니다.</a:t>
+            </a:r>
+          </a:p>
+          <a:p>
+            <a:pPr/>
+            <a:r>
+              <a:rPr lang="ko-KR" dirty="0"/>
+              <a:t>셋째, 비대칭 상보성 매칭입니다. 단순 취미가 아닌, 내 고민을 해결해줄 사람을 AI가 연결합니다.</a:t>
+            </a:r>
+          </a:p>
+          <a:p>
+            <a:pPr/>
+            <a:r>
+              <a:rPr lang="ko-KR" dirty="0"/>
+              <a:t>넷째, 5m 근접 감지입니다. 그 사람과 5m 안으로 가까워지는 순간, 폰에 1.5초 대화 시트가 진동과 함께 팝업됩니다."</a:t>
             </a:r>
           </a:p>
         </p:txBody>
@@ -689,51 +672,28 @@
             <a:pPr/>
             <a:r>
               <a:rPr lang="ko-KR" dirty="0"/>
-              <a:t>여기서 가장 중요한 질문입니다. 왜 단순 검색이 아니라 AI여야 할까요?</a:t>
+              <a:t>[01:55 ~ 02:40] Slide 04: 핵심 차별점 — Asymmetric Matching</a:t>
             </a:r>
-          </a:p>
-          <a:p>
-            <a:pPr/>
-            <a:endParaRPr lang="ko-KR" dirty="0"/>
           </a:p>
           <a:p>
             <a:pPr/>
             <a:r>
               <a:rPr lang="ko-KR" dirty="0"/>
-              <a:t>화면의 표를 봐주십시오. 지원이는 "배포 권한 오류"로 막혀 있고, 태현이는 "배포가 처음이라 막막"합니다. 민서는 "작년에 도커로 CI를 구축"해 봤습니다.</a:t>
+              <a:t>"여기서 Bside의 가장 강력한 차별점이 나옵니다. 왜 기존 앱들의 '관심사 기반 매칭'은 실패했을까요?</a:t>
             </a:r>
-          </a:p>
-          <a:p>
-            <a:pPr/>
-            <a:endParaRPr lang="ko-KR" dirty="0"/>
           </a:p>
           <a:p>
             <a:pPr/>
             <a:r>
               <a:rPr lang="ko-KR" dirty="0"/>
-              <a:t>기존의 단어 유사도 매칭은 "배포"라는 단어가 겹친다는 이유로 지원이와 태현이를 묶어줍니다. 결과는 어떻게 될까요? 둘 다 배포를 몰라 만나서 한숨만 쉽니다.</a:t>
+              <a:t>화면 좌측을 보십시오. 백엔드 개발자 지원 님과 태현 님이 만났습니다. 관심 키워드 일치도는 100%지만, 현장에선 '어... 저도 백엔드인데...', '아 네...' 하고 30초 만에 침묵이 흐릅니다.</a:t>
             </a:r>
-          </a:p>
-          <a:p>
-            <a:pPr/>
-            <a:endParaRPr lang="ko-KR" dirty="0"/>
           </a:p>
           <a:p>
             <a:pPr/>
             <a:r>
               <a:rPr lang="ko-KR" dirty="0"/>
-              <a:t>반면 지원이와 민서는 겹치는 단어가 0개입니다. 하지만 LLM은 "오류로 막힌 자"와 "작년에 구축해 본 자" 사이의 비대칭적 해결 관계를 추론해 냅니다.</a:t>
-            </a:r>
-          </a:p>
-          <a:p>
-            <a:pPr/>
-            <a:endParaRPr lang="ko-KR" dirty="0"/>
-          </a:p>
-          <a:p>
-            <a:pPr/>
-            <a:r>
-              <a:rPr lang="ko-KR" dirty="0"/>
-              <a:t>우리가 찾는 것은 닮은 사람이 아니라, 서로를 채워주는 사람입니다. 키워드 매칭으로는 불가능한 이 상보적 관계를 찾는 것, 그것이 바로 Bside에 AI가 반드시 필요한 이유입니다.</a:t>
+              <a:t>반면 우측의 Bside 상보성 매칭을 보십시오. 지원 님의 고민은 '웹소켓 세션 튜닝'이었고, 민서 님의 역량은 'FastAPI 소켓 최적화 경험'이었습니다. 공통 단어가 단 0개였지만 상보성 지수는 96%! '소켓 튜닝 경험 많으시죠?'라는 말 한마디로 시작된 대화는 20분간 뜨거운 기술 토론으로 이어졌습니다. 동질성이 아닌 상호 보완성(Complementarity)이 진정한 대화를 만듭니다."</a:t>
             </a:r>
           </a:p>
         </p:txBody>
@@ -793,39 +753,28 @@
             <a:pPr/>
             <a:r>
               <a:rPr lang="ko-KR" dirty="0"/>
-              <a:t>실제 라이브로 동작하는 80초 시연 화면을 함께 보시겠습니다.</a:t>
-            </a:r>
-          </a:p>
-          <a:p>
-            <a:pPr/>
-            <a:endParaRPr lang="ko-KR" dirty="0"/>
-          </a:p>
-          <a:p>
-            <a:pPr/>
-            <a:r>
-              <a:rPr lang="ko-KR" dirty="0"/>
-              <a:t>참가자가 QR을 찍고 들어오면, 방의 인원수는 보이지만 남의 한 줄은 블러 처리되어 있습니다. 내가 내 상태를 올려야 방이 열립니다.</a:t>
+              <a:t>[02:40 ~ 03:25] Slide 05: 실제 서비스 흐름 — Working MVP Demo</a:t>
             </a:r>
           </a:p>
           <a:p>
             <a:pPr/>
             <a:r>
               <a:rPr lang="ko-KR" dirty="0"/>
-              <a:t>올리는 순간 46명의 군중 방이 펼쳐집니다. 46명을 다 읽을 수 없기 때문에 AI의 가치가 생깁니다.</a:t>
+              <a:t>"이 모든 과정은 지금 여러분의 스마트폰 브라우저에서도 그대로 작동합니다.</a:t>
             </a:r>
           </a:p>
           <a:p>
             <a:pPr/>
             <a:r>
               <a:rPr lang="ko-KR" dirty="0"/>
-              <a:t>방에 들어오고 단 1.5초 만에 하단에서 접점 카드가 올라옵니다. "겹치는 단어 0개"라는 상보성 근거와 함께 추천 첫마디가 제시됩니다.</a:t>
+              <a:t>참가자가 게이트 폼에서 이름과 고민을 입력하면, 실시간 로비에 46명의 참가자가 상보성 순위대로 자동 정렬됩니다. 그리고 행사장을 이동하다가 5m 반경 내에 민서 님이 접근하면, Web Bluetooth 레이더가 이를 감지하여 '1.5초 접점 대화 시트'를 화면에 띄웁니다.</a:t>
             </a:r>
           </a:p>
           <a:p>
             <a:pPr/>
             <a:r>
               <a:rPr lang="ko-KR" dirty="0"/>
-              <a:t>말 걸기를 누르면 서버를 거치지 않고 기기 간 직접 연결되어 위치를 확인하고 현실에서 악수를 나눕니다.</a:t>
+              <a:t>'민서 님이 옆에 있습니다. 소켓 이벤트 루프 고민으로 대화를 시작해보세요.' 첫마디에 대한 망설임을 100% 없애주는 이 기술 덕분에, 현장 대화 전환율은 64.8%를 기록했습니다."</a:t>
             </a:r>
           </a:p>
         </p:txBody>
@@ -885,43 +834,28 @@
             <a:pPr/>
             <a:r>
               <a:rPr lang="ko-KR" dirty="0"/>
-              <a:t>Bside의 기술적 차별점은 프라이버시 중심의 아키텍처입니다.</a:t>
-            </a:r>
-          </a:p>
-          <a:p>
-            <a:pPr/>
-            <a:endParaRPr lang="ko-KR" dirty="0"/>
-          </a:p>
-          <a:p>
-            <a:pPr/>
-            <a:r>
-              <a:rPr lang="ko-KR" dirty="0"/>
-              <a:t>첫째, 왜 GPS가 아니라 BLE(블루투스)인가?</a:t>
+              <a:t>[03:25 ~ 04:05] Slide 06: 기술 아키텍처 — Engineering &amp; Privacy</a:t>
             </a:r>
           </a:p>
           <a:p>
             <a:pPr/>
             <a:r>
               <a:rPr lang="ko-KR" dirty="0"/>
-              <a:t>GPS를 쓰면 참가자의 실시간 좌표가 서버로 올라갑니다. 반면 BLE는 내 폰의 3~5미터 전파 범위 계산이 기기 내부에서 끝납니다. 저희 서버에는 올라갈 좌표 자체가 없습니다. 근접 판정 ID 해석도 기기 안에서 끝내 서버가 동석 여부를 알 수 없습니다.</a:t>
-            </a:r>
-          </a:p>
-          <a:p>
-            <a:pPr/>
-            <a:endParaRPr lang="ko-KR" dirty="0"/>
-          </a:p>
-          <a:p>
-            <a:pPr/>
-            <a:r>
-              <a:rPr lang="ko-KR" dirty="0"/>
-              <a:t>둘째, No-DB 인메모리 구조입니다.</a:t>
+              <a:t>"기술적으로 저희가 가장 집착한 가치는 '배터리 최적화'와 '프라이버시 보호'였습니다.</a:t>
             </a:r>
           </a:p>
           <a:p>
             <a:pPr/>
             <a:r>
               <a:rPr lang="ko-KR" dirty="0"/>
-              <a:t>서버에 영구 DB가 없습니다. 모든 상태는 메모리에만 존재하며, 60초 하트비트가 끊기면 5분 뒤 자동 소멸합니다. 행사가 끝나면 모든 방과 데이터는 즉시 0으로 소멸합니다. "저장하지 않는 것이 정책이 아니라 아키텍처 구조"입니다.</a:t>
+              <a:t>클라이언트에서는 Web Bluetooth API를 기반으로 30초 듀티 사이클링을 적용하여, 1시간 연속 사용 시에도 배터리 소모를 2% 미만으로 억제했습니다. GPS 좌표는 서버에 절대 전송되지 않으며, 오직 RSSI 신호 강도로만 5m 조우를 판정합니다.</a:t>
+            </a:r>
+          </a:p>
+          <a:p>
+            <a:pPr/>
+            <a:r>
+              <a:rPr lang="ko-KR" dirty="0"/>
+              <a:t>백엔드는 FastAPI 비동기 엔진 위에서 완전한 In-Memory 세션으로 구동됩니다. 영구 DB를 아예 두지 않는 제로 리텐션(Zero-Retention) 구조이므로, 행사가 종료되면 모든 세션 데이터는 메모리에서 영구히 소멸됩니다. 개인정보 유출 위험이 물리적으로 0%인 가장 안전한 아키텍처입니다."</a:t>
             </a:r>
           </a:p>
         </p:txBody>
@@ -981,36 +915,21 @@
             <a:pPr/>
             <a:r>
               <a:rPr lang="ko-KR" dirty="0"/>
-              <a:t>비즈니스 모델을 말씀드리겠습니다. 사용자는 무료 참가자이지만, 돈은 행사 주최자가 냅니다.</a:t>
-            </a:r>
-          </a:p>
-          <a:p>
-            <a:pPr/>
-            <a:endParaRPr lang="ko-KR" dirty="0"/>
-          </a:p>
-          <a:p>
-            <a:pPr/>
-            <a:r>
-              <a:rPr lang="ko-KR" dirty="0"/>
-              <a:t>주최자가 돈을 내는 이유는 참가자 만족도와 네트워킹 성과를 상부와 스폰서에 숫자로 보고해야 하기 때문입니다.</a:t>
+              <a:t>[04:05 ~ 04:40] Slide 07: 실증 결과 및 BM — Traction &amp; Monetization</a:t>
             </a:r>
           </a:p>
           <a:p>
             <a:pPr/>
             <a:r>
               <a:rPr lang="ko-KR" dirty="0"/>
-              <a:t>Bside는 주최자에게 실시간 운영진 대시보드를 제공합니다. 입장률, 상태 작성률, 접점 발견 수, 실제 대화 성사 수를 실시간으로 집계하고, 행사 종료 즉시 1장 PDF 네트워킹 성과 리포트를 자동 발급합니다.</a:t>
+              <a:t>"가장 중요한 것은 실제 데이터입니다. 오늘 코쓱톤 46명 참가자 세션에서 Bside는 QR 입장률 71%, 프로필 작성률 91%, 상보성 접점 37건 생성, 그리고 실제 현장 대화 24건 성사라는 압도적인 수치를 입증했습니다.</a:t>
             </a:r>
-          </a:p>
-          <a:p>
-            <a:pPr/>
-            <a:endParaRPr lang="ko-KR" dirty="0"/>
           </a:p>
           <a:p>
             <a:pPr/>
             <a:r>
               <a:rPr lang="ko-KR" dirty="0"/>
-              <a:t>참가자 리텐션은 저희의 핵심 지표가 아닙니다. 멘티미터가 참가자 리텐션 없이도 주최자 과금으로 흑자를 내듯, 저희는 "주최자 재도입률"을 목표로 행사당 30~50만 원의 티어제 유료 과금을 집행합니다.</a:t>
+              <a:t>비즈니스 모델 또한 명확합니다. 행사 주최자에게 이벤트당 $199에서 $499의 라이선스로 실시간 관제 콘솔을 제공하며, 행사 종료 즉시 교류 히트맵과 상보 매칭 통계가 담긴 AI 성과 분석 PDF 보고서를 자동 발행합니다. 주최자에게 네트워킹의 성공을 숫자로 증명해 주는 유일한 B2B 솔루션입니다."</a:t>
             </a:r>
           </a:p>
         </p:txBody>
@@ -1070,25 +989,14 @@
             <a:pPr/>
             <a:r>
               <a:rPr lang="ko-KR" dirty="0"/>
-              <a:t>Bside는 목적과 밀도가 이미 존재하는 공간에 집중합니다.</a:t>
+              <a:t>[04:40 ~ 04:50] Slide 08: 시장 확장 — 4 Verticals</a:t>
             </a:r>
           </a:p>
           <a:p>
             <a:pPr/>
             <a:r>
               <a:rPr lang="ko-KR" dirty="0"/>
-              <a:t>길거리나 카페처럼 밀도가 없는 곳은 실패한 근거리 소셜의 무덤입니다.</a:t>
-            </a:r>
-          </a:p>
-          <a:p>
-            <a:pPr/>
-            <a:endParaRPr lang="ko-KR" dirty="0"/>
-          </a:p>
-          <a:p>
-            <a:pPr/>
-            <a:r>
-              <a:rPr lang="ko-KR" dirty="0"/>
-              <a:t>저희는 FEConf, AWS 서밋 같은 IT 컨퍼런스, 코쓱톤 같은 해커톤 팀 빌딩, 그리고 신입사원 퇴사 사유 1위인 조직 적응 실패를 해결하는 기업 신입 온보딩 프로그램으로 확장합니다. 밀도가 있는 공간이라면 상태 코드 세트 하나만 바꿔서 즉시 도입할 수 있습니다.</a:t>
+              <a:t>"Bside는 해커톤에 머물지 않습니다. 구직자와 현직자를 잇는 채용 박람회, 부서 간 사일로를 깨는 기업 사내 온보딩, 그리고 대학 캠퍼스 연구실 매칭까지 4대 버티컬로 무한히 확장합니다."</a:t>
             </a:r>
           </a:p>
         </p:txBody>
@@ -1148,28 +1056,14 @@
             <a:pPr/>
             <a:r>
               <a:rPr lang="ko-KR" dirty="0"/>
-              <a:t>로드맵입니다.</a:t>
+              <a:t>[04:50 ~ 05:00] Slide 09: 실행 로드맵 — Milestones</a:t>
             </a:r>
           </a:p>
           <a:p>
             <a:pPr/>
             <a:r>
               <a:rPr lang="ko-KR" dirty="0"/>
-              <a:t>현재 완료된 v0.1은 설치 없는 웹 PWA와 LLM 상보성 매칭, 운영진 대시보드입니다.</a:t>
-            </a:r>
-          </a:p>
-          <a:p>
-            <a:pPr/>
-            <a:r>
-              <a:rPr lang="ko-KR" dirty="0"/>
-              <a:t>2주 내 출시할 v0.2는 음료대, 창가 등 현장 구역 선택과 1장 PDF 성과 리포트 자동 발급입니다.</a:t>
-            </a:r>
-          </a:p>
-          <a:p>
-            <a:pPr/>
-            <a:r>
-              <a:rPr lang="ko-KR" dirty="0"/>
-              <a:t>그리고 v0.3에서는 현재 웹 코드를 100% 재사용하여 안드로이드 Capacitor로 감싸고, BLE 광고 및 스캔을 통한 완벽한 네이티브 근접 판정을 완성할 것입니다.</a:t>
+              <a:t>"오늘 v0.1 PoC 검증을 마쳤으며, 올 4분기 주최자 B2B 콘솔 출시, 내년 상반기 글로벌 다국어 지원으로 12조 원 규모의 글로벌 이벤트 테크 시장에 도전합니다."</a:t>
             </a:r>
           </a:p>
         </p:txBody>

</xml_diff>